<commit_message>
Document HF model publishing + phone identification
README: new "Publishing a model & identifying on a phone" section covering
push_model.py, auto-discovery in the herbarium-id Space, phone usage, and
calibrated confidence.

Intro deck: new slide "Publish & Identify on a Phone" (checkpoint -> HF Hub
model repo -> Space flow, publishing/phone bullets, phone mockup, live URL).
Regenerated herbarium_pipeline_intro.pptx (18 slides).

Co-Authored-By: Claude Opus 4.8 <noreply@anthropic.com>
</commit_message>
<xml_diff>
--- a/herbarium_pipeline_intro.pptx
+++ b/herbarium_pipeline_intro.pptx
@@ -22,6 +22,7 @@
     <p:sldId id="270" r:id="rId21"/>
     <p:sldId id="271" r:id="rId22"/>
     <p:sldId id="272" r:id="rId23"/>
+    <p:sldId id="273" r:id="rId24"/>
   </p:sldIdLst>
   <p:sldSz cx="12188952" cy="6858000" type="screen4x3"/>
   <p:notesSz cx="6858000" cy="9144000"/>
@@ -13739,6 +13740,1339 @@
                 </a:solidFill>
               </a:rPr>
               <a:t>Identify tab → Run and check predictions.csv</a:t>
+            </a:r>
+          </a:p>
+        </p:txBody>
+      </p:sp>
+    </p:spTree>
+  </p:cSld>
+  <p:clrMapOvr>
+    <a:masterClrMapping/>
+  </p:clrMapOvr>
+</p:sld>
+</file>
+
+<file path=ppt/slides/slide18.xml><?xml version="1.0" encoding="utf-8"?>
+<p:sld xmlns:a="http://schemas.openxmlformats.org/drawingml/2006/main" xmlns:p="http://schemas.openxmlformats.org/presentationml/2006/main" xmlns:r="http://schemas.openxmlformats.org/officeDocument/2006/relationships">
+  <p:cSld>
+    <p:spTree>
+      <p:nvGrpSpPr>
+        <p:cNvPr id="1" name=""/>
+        <p:cNvGrpSpPr/>
+        <p:nvPr/>
+      </p:nvGrpSpPr>
+      <p:grpSpPr/>
+      <p:sp>
+        <p:nvSpPr>
+          <p:cNvPr id="2" name="Rectangle 1"/>
+          <p:cNvSpPr/>
+          <p:nvPr/>
+        </p:nvSpPr>
+        <p:spPr>
+          <a:xfrm>
+            <a:off x="0" y="0"/>
+            <a:ext cx="12188952" cy="1051560"/>
+          </a:xfrm>
+          <a:prstGeom prst="rect">
+            <a:avLst/>
+          </a:prstGeom>
+          <a:solidFill>
+            <a:srgbClr val="00695C"/>
+          </a:solidFill>
+          <a:ln>
+            <a:noFill/>
+          </a:ln>
+        </p:spPr>
+        <p:style>
+          <a:lnRef idx="1">
+            <a:schemeClr val="accent1"/>
+          </a:lnRef>
+          <a:fillRef idx="3">
+            <a:schemeClr val="accent1"/>
+          </a:fillRef>
+          <a:effectRef idx="2">
+            <a:schemeClr val="accent1"/>
+          </a:effectRef>
+          <a:fontRef idx="minor">
+            <a:schemeClr val="lt1"/>
+          </a:fontRef>
+        </p:style>
+        <p:txBody>
+          <a:bodyPr rtlCol="0" anchor="ctr"/>
+          <a:lstStyle/>
+          <a:p>
+            <a:pPr algn="ctr"/>
+          </a:p>
+        </p:txBody>
+      </p:sp>
+      <p:sp>
+        <p:nvSpPr>
+          <p:cNvPr id="3" name="Rectangle 2"/>
+          <p:cNvSpPr/>
+          <p:nvPr/>
+        </p:nvSpPr>
+        <p:spPr>
+          <a:xfrm>
+            <a:off x="0" y="1051560"/>
+            <a:ext cx="12188952" cy="41148"/>
+          </a:xfrm>
+          <a:prstGeom prst="rect">
+            <a:avLst/>
+          </a:prstGeom>
+          <a:solidFill>
+            <a:srgbClr val="00897B"/>
+          </a:solidFill>
+          <a:ln>
+            <a:noFill/>
+          </a:ln>
+        </p:spPr>
+        <p:style>
+          <a:lnRef idx="1">
+            <a:schemeClr val="accent1"/>
+          </a:lnRef>
+          <a:fillRef idx="3">
+            <a:schemeClr val="accent1"/>
+          </a:fillRef>
+          <a:effectRef idx="2">
+            <a:schemeClr val="accent1"/>
+          </a:effectRef>
+          <a:fontRef idx="minor">
+            <a:schemeClr val="lt1"/>
+          </a:fontRef>
+        </p:style>
+        <p:txBody>
+          <a:bodyPr rtlCol="0" anchor="ctr"/>
+          <a:lstStyle/>
+          <a:p>
+            <a:pPr algn="ctr"/>
+          </a:p>
+        </p:txBody>
+      </p:sp>
+      <p:sp>
+        <p:nvSpPr>
+          <p:cNvPr id="4" name="TextBox 3"/>
+          <p:cNvSpPr txBox="1"/>
+          <p:nvPr/>
+        </p:nvSpPr>
+        <p:spPr>
+          <a:xfrm>
+            <a:off x="411480" y="137160"/>
+            <a:ext cx="11338560" cy="640080"/>
+          </a:xfrm>
+          <a:prstGeom prst="rect">
+            <a:avLst/>
+          </a:prstGeom>
+          <a:noFill/>
+        </p:spPr>
+        <p:txBody>
+          <a:bodyPr wrap="square">
+            <a:spAutoFit/>
+          </a:bodyPr>
+          <a:lstStyle/>
+          <a:p>
+            <a:pPr algn="l"/>
+            <a:r>
+              <a:rPr sz="2600" b="1" i="0">
+                <a:solidFill>
+                  <a:srgbClr val="FFFFFF"/>
+                </a:solidFill>
+              </a:rPr>
+              <a:t>Publish &amp; Identify on a Phone</a:t>
+            </a:r>
+          </a:p>
+        </p:txBody>
+      </p:sp>
+      <p:sp>
+        <p:nvSpPr>
+          <p:cNvPr id="5" name="TextBox 4"/>
+          <p:cNvSpPr txBox="1"/>
+          <p:nvPr/>
+        </p:nvSpPr>
+        <p:spPr>
+          <a:xfrm>
+            <a:off x="411480" y="713232"/>
+            <a:ext cx="11338560" cy="320040"/>
+          </a:xfrm>
+          <a:prstGeom prst="rect">
+            <a:avLst/>
+          </a:prstGeom>
+          <a:noFill/>
+        </p:spPr>
+        <p:txBody>
+          <a:bodyPr wrap="square">
+            <a:spAutoFit/>
+          </a:bodyPr>
+          <a:lstStyle/>
+          <a:p>
+            <a:pPr algn="l"/>
+            <a:r>
+              <a:rPr sz="1200" b="0" i="0">
+                <a:solidFill>
+                  <a:srgbClr val="80CBC4"/>
+                </a:solidFill>
+              </a:rPr>
+              <a:t>Publish a trained model to the Hugging Face Hub — anyone identifies specimens from a phone browser, no install</a:t>
+            </a:r>
+          </a:p>
+        </p:txBody>
+      </p:sp>
+      <p:sp>
+        <p:nvSpPr>
+          <p:cNvPr id="6" name="Rectangle 5"/>
+          <p:cNvSpPr/>
+          <p:nvPr/>
+        </p:nvSpPr>
+        <p:spPr>
+          <a:xfrm>
+            <a:off x="0" y="6510528"/>
+            <a:ext cx="12188952" cy="347472"/>
+          </a:xfrm>
+          <a:prstGeom prst="rect">
+            <a:avLst/>
+          </a:prstGeom>
+          <a:solidFill>
+            <a:srgbClr val="F0F2F4"/>
+          </a:solidFill>
+          <a:ln>
+            <a:noFill/>
+          </a:ln>
+        </p:spPr>
+        <p:style>
+          <a:lnRef idx="1">
+            <a:schemeClr val="accent1"/>
+          </a:lnRef>
+          <a:fillRef idx="3">
+            <a:schemeClr val="accent1"/>
+          </a:fillRef>
+          <a:effectRef idx="2">
+            <a:schemeClr val="accent1"/>
+          </a:effectRef>
+          <a:fontRef idx="minor">
+            <a:schemeClr val="lt1"/>
+          </a:fontRef>
+        </p:style>
+        <p:txBody>
+          <a:bodyPr rtlCol="0" anchor="ctr"/>
+          <a:lstStyle/>
+          <a:p>
+            <a:pPr algn="ctr"/>
+          </a:p>
+        </p:txBody>
+      </p:sp>
+      <p:sp>
+        <p:nvSpPr>
+          <p:cNvPr id="7" name="TextBox 6"/>
+          <p:cNvSpPr txBox="1"/>
+          <p:nvPr/>
+        </p:nvSpPr>
+        <p:spPr>
+          <a:xfrm>
+            <a:off x="411480" y="6528816"/>
+            <a:ext cx="10972800" cy="310896"/>
+          </a:xfrm>
+          <a:prstGeom prst="rect">
+            <a:avLst/>
+          </a:prstGeom>
+          <a:noFill/>
+        </p:spPr>
+        <p:txBody>
+          <a:bodyPr wrap="square">
+            <a:spAutoFit/>
+          </a:bodyPr>
+          <a:lstStyle/>
+          <a:p>
+            <a:pPr algn="l"/>
+            <a:r>
+              <a:rPr sz="1000" b="0" i="0">
+                <a:solidFill>
+                  <a:srgbClr val="455A64"/>
+                </a:solidFill>
+              </a:rPr>
+              <a:t>Herbarium Classification Pipeline</a:t>
+            </a:r>
+          </a:p>
+        </p:txBody>
+      </p:sp>
+      <p:sp>
+        <p:nvSpPr>
+          <p:cNvPr id="8" name="Rounded Rectangle 7"/>
+          <p:cNvSpPr/>
+          <p:nvPr/>
+        </p:nvSpPr>
+        <p:spPr>
+          <a:xfrm>
+            <a:off x="365760" y="1399032"/>
+            <a:ext cx="2286000" cy="960120"/>
+          </a:xfrm>
+          <a:prstGeom prst="roundRect">
+            <a:avLst/>
+          </a:prstGeom>
+          <a:solidFill>
+            <a:srgbClr val="00897B"/>
+          </a:solidFill>
+          <a:ln>
+            <a:noFill/>
+          </a:ln>
+        </p:spPr>
+        <p:style>
+          <a:lnRef idx="1">
+            <a:schemeClr val="accent1"/>
+          </a:lnRef>
+          <a:fillRef idx="3">
+            <a:schemeClr val="accent1"/>
+          </a:fillRef>
+          <a:effectRef idx="2">
+            <a:schemeClr val="accent1"/>
+          </a:effectRef>
+          <a:fontRef idx="minor">
+            <a:schemeClr val="lt1"/>
+          </a:fontRef>
+        </p:style>
+        <p:txBody>
+          <a:bodyPr rtlCol="0" anchor="ctr" wrap="square"/>
+          <a:lstStyle/>
+          <a:p>
+            <a:pPr algn="ctr"/>
+            <a:r>
+              <a:rPr sz="1200" b="1">
+                <a:solidFill>
+                  <a:srgbClr val="FFFFFF"/>
+                </a:solidFill>
+              </a:rPr>
+              <a:t>Trained
+checkpoint
+.ckpt</a:t>
+            </a:r>
+          </a:p>
+        </p:txBody>
+      </p:sp>
+      <p:sp>
+        <p:nvSpPr>
+          <p:cNvPr id="9" name="Can 8"/>
+          <p:cNvSpPr/>
+          <p:nvPr/>
+        </p:nvSpPr>
+        <p:spPr>
+          <a:xfrm>
+            <a:off x="2697480" y="1746504"/>
+            <a:ext cx="1234440" cy="256032"/>
+          </a:xfrm>
+          <a:prstGeom prst="can">
+            <a:avLst/>
+          </a:prstGeom>
+          <a:solidFill>
+            <a:srgbClr val="00897B"/>
+          </a:solidFill>
+          <a:ln>
+            <a:noFill/>
+          </a:ln>
+        </p:spPr>
+        <p:style>
+          <a:lnRef idx="1">
+            <a:schemeClr val="accent1"/>
+          </a:lnRef>
+          <a:fillRef idx="3">
+            <a:schemeClr val="accent1"/>
+          </a:fillRef>
+          <a:effectRef idx="2">
+            <a:schemeClr val="accent1"/>
+          </a:effectRef>
+          <a:fontRef idx="minor">
+            <a:schemeClr val="lt1"/>
+          </a:fontRef>
+        </p:style>
+        <p:txBody>
+          <a:bodyPr rtlCol="0" anchor="ctr"/>
+          <a:lstStyle/>
+          <a:p>
+            <a:pPr algn="ctr"/>
+          </a:p>
+        </p:txBody>
+      </p:sp>
+      <p:sp>
+        <p:nvSpPr>
+          <p:cNvPr id="10" name="TextBox 9"/>
+          <p:cNvSpPr txBox="1"/>
+          <p:nvPr/>
+        </p:nvSpPr>
+        <p:spPr>
+          <a:xfrm>
+            <a:off x="2697480" y="1581912"/>
+            <a:ext cx="1234440" cy="256032"/>
+          </a:xfrm>
+          <a:prstGeom prst="rect">
+            <a:avLst/>
+          </a:prstGeom>
+          <a:noFill/>
+        </p:spPr>
+        <p:txBody>
+          <a:bodyPr wrap="square">
+            <a:spAutoFit/>
+          </a:bodyPr>
+          <a:lstStyle/>
+          <a:p>
+            <a:pPr algn="ctr"/>
+            <a:r>
+              <a:rPr sz="900" b="0" i="0">
+                <a:solidFill>
+                  <a:srgbClr val="455A64"/>
+                </a:solidFill>
+              </a:rPr>
+              <a:t>push_model.py</a:t>
+            </a:r>
+          </a:p>
+        </p:txBody>
+      </p:sp>
+      <p:sp>
+        <p:nvSpPr>
+          <p:cNvPr id="11" name="Rounded Rectangle 10"/>
+          <p:cNvSpPr/>
+          <p:nvPr/>
+        </p:nvSpPr>
+        <p:spPr>
+          <a:xfrm>
+            <a:off x="4023360" y="1399032"/>
+            <a:ext cx="3200400" cy="960120"/>
+          </a:xfrm>
+          <a:prstGeom prst="roundRect">
+            <a:avLst/>
+          </a:prstGeom>
+          <a:solidFill>
+            <a:srgbClr val="015F9B"/>
+          </a:solidFill>
+          <a:ln>
+            <a:noFill/>
+          </a:ln>
+        </p:spPr>
+        <p:style>
+          <a:lnRef idx="1">
+            <a:schemeClr val="accent1"/>
+          </a:lnRef>
+          <a:fillRef idx="3">
+            <a:schemeClr val="accent1"/>
+          </a:fillRef>
+          <a:effectRef idx="2">
+            <a:schemeClr val="accent1"/>
+          </a:effectRef>
+          <a:fontRef idx="minor">
+            <a:schemeClr val="lt1"/>
+          </a:fontRef>
+        </p:style>
+        <p:txBody>
+          <a:bodyPr rtlCol="0" anchor="ctr" wrap="square"/>
+          <a:lstStyle/>
+          <a:p>
+            <a:pPr algn="ctr"/>
+            <a:r>
+              <a:rPr sz="1200" b="1">
+                <a:solidFill>
+                  <a:srgbClr val="FFFFFF"/>
+                </a:solidFill>
+              </a:rPr>
+              <a:t>Hugging Face Hub
+model repo</a:t>
+            </a:r>
+          </a:p>
+          <a:p>
+            <a:pPr algn="ctr"/>
+            <a:r>
+              <a:rPr sz="1000">
+                <a:solidFill>
+                  <a:srgbClr val="FFFFFF"/>
+                </a:solidFill>
+              </a:rPr>
+              <a:t>model.ckpt · nameslist · config.json</a:t>
+            </a:r>
+          </a:p>
+        </p:txBody>
+      </p:sp>
+      <p:sp>
+        <p:nvSpPr>
+          <p:cNvPr id="12" name="Can 11"/>
+          <p:cNvSpPr/>
+          <p:nvPr/>
+        </p:nvSpPr>
+        <p:spPr>
+          <a:xfrm>
+            <a:off x="7269480" y="1746504"/>
+            <a:ext cx="1234440" cy="256032"/>
+          </a:xfrm>
+          <a:prstGeom prst="can">
+            <a:avLst/>
+          </a:prstGeom>
+          <a:solidFill>
+            <a:srgbClr val="015F9B"/>
+          </a:solidFill>
+          <a:ln>
+            <a:noFill/>
+          </a:ln>
+        </p:spPr>
+        <p:style>
+          <a:lnRef idx="1">
+            <a:schemeClr val="accent1"/>
+          </a:lnRef>
+          <a:fillRef idx="3">
+            <a:schemeClr val="accent1"/>
+          </a:fillRef>
+          <a:effectRef idx="2">
+            <a:schemeClr val="accent1"/>
+          </a:effectRef>
+          <a:fontRef idx="minor">
+            <a:schemeClr val="lt1"/>
+          </a:fontRef>
+        </p:style>
+        <p:txBody>
+          <a:bodyPr rtlCol="0" anchor="ctr"/>
+          <a:lstStyle/>
+          <a:p>
+            <a:pPr algn="ctr"/>
+          </a:p>
+        </p:txBody>
+      </p:sp>
+      <p:sp>
+        <p:nvSpPr>
+          <p:cNvPr id="13" name="TextBox 12"/>
+          <p:cNvSpPr txBox="1"/>
+          <p:nvPr/>
+        </p:nvSpPr>
+        <p:spPr>
+          <a:xfrm>
+            <a:off x="7269480" y="1581912"/>
+            <a:ext cx="1234440" cy="256032"/>
+          </a:xfrm>
+          <a:prstGeom prst="rect">
+            <a:avLst/>
+          </a:prstGeom>
+          <a:noFill/>
+        </p:spPr>
+        <p:txBody>
+          <a:bodyPr wrap="square">
+            <a:spAutoFit/>
+          </a:bodyPr>
+          <a:lstStyle/>
+          <a:p>
+            <a:pPr algn="ctr"/>
+            <a:r>
+              <a:rPr sz="900" b="0" i="0">
+                <a:solidFill>
+                  <a:srgbClr val="455A64"/>
+                </a:solidFill>
+              </a:rPr>
+              <a:t>auto-discovered</a:t>
+            </a:r>
+          </a:p>
+        </p:txBody>
+      </p:sp>
+      <p:sp>
+        <p:nvSpPr>
+          <p:cNvPr id="14" name="Rounded Rectangle 13"/>
+          <p:cNvSpPr/>
+          <p:nvPr/>
+        </p:nvSpPr>
+        <p:spPr>
+          <a:xfrm>
+            <a:off x="8595360" y="1399032"/>
+            <a:ext cx="3200400" cy="960120"/>
+          </a:xfrm>
+          <a:prstGeom prst="roundRect">
+            <a:avLst/>
+          </a:prstGeom>
+          <a:solidFill>
+            <a:srgbClr val="00695C"/>
+          </a:solidFill>
+          <a:ln>
+            <a:noFill/>
+          </a:ln>
+        </p:spPr>
+        <p:style>
+          <a:lnRef idx="1">
+            <a:schemeClr val="accent1"/>
+          </a:lnRef>
+          <a:fillRef idx="3">
+            <a:schemeClr val="accent1"/>
+          </a:fillRef>
+          <a:effectRef idx="2">
+            <a:schemeClr val="accent1"/>
+          </a:effectRef>
+          <a:fontRef idx="minor">
+            <a:schemeClr val="lt1"/>
+          </a:fontRef>
+        </p:style>
+        <p:txBody>
+          <a:bodyPr rtlCol="0" anchor="ctr" wrap="square"/>
+          <a:lstStyle/>
+          <a:p>
+            <a:pPr algn="ctr"/>
+            <a:r>
+              <a:rPr sz="1200" b="1">
+                <a:solidFill>
+                  <a:srgbClr val="FFFFFF"/>
+                </a:solidFill>
+              </a:rPr>
+              <a:t>herbarium-id Space
+Gradio · free CPU tier</a:t>
+            </a:r>
+          </a:p>
+        </p:txBody>
+      </p:sp>
+      <p:sp>
+        <p:nvSpPr>
+          <p:cNvPr id="15" name="TextBox 14"/>
+          <p:cNvSpPr txBox="1"/>
+          <p:nvPr/>
+        </p:nvSpPr>
+        <p:spPr>
+          <a:xfrm>
+            <a:off x="365760" y="2633472"/>
+            <a:ext cx="5486400" cy="365760"/>
+          </a:xfrm>
+          <a:prstGeom prst="rect">
+            <a:avLst/>
+          </a:prstGeom>
+          <a:noFill/>
+        </p:spPr>
+        <p:txBody>
+          <a:bodyPr wrap="square">
+            <a:spAutoFit/>
+          </a:bodyPr>
+          <a:lstStyle/>
+          <a:p>
+            <a:pPr algn="l"/>
+            <a:r>
+              <a:rPr sz="1400" b="1" i="0">
+                <a:solidFill>
+                  <a:srgbClr val="00695C"/>
+                </a:solidFill>
+              </a:rPr>
+              <a:t>Publishing a model</a:t>
+            </a:r>
+          </a:p>
+        </p:txBody>
+      </p:sp>
+      <p:sp>
+        <p:nvSpPr>
+          <p:cNvPr id="16" name="TextBox 15"/>
+          <p:cNvSpPr txBox="1"/>
+          <p:nvPr/>
+        </p:nvSpPr>
+        <p:spPr>
+          <a:xfrm>
+            <a:off x="365760" y="3044951"/>
+            <a:ext cx="5577840" cy="2377440"/>
+          </a:xfrm>
+          <a:prstGeom prst="rect">
+            <a:avLst/>
+          </a:prstGeom>
+          <a:noFill/>
+        </p:spPr>
+        <p:txBody>
+          <a:bodyPr wrap="square">
+            <a:spAutoFit/>
+          </a:bodyPr>
+          <a:lstStyle/>
+          <a:p>
+            <a:pPr>
+              <a:spcBef>
+                <a:spcPts val="400"/>
+              </a:spcBef>
+            </a:pPr>
+            <a:r>
+              <a:rPr sz="1200">
+                <a:solidFill>
+                  <a:srgbClr val="1A2027"/>
+                </a:solidFill>
+              </a:rPr>
+              <a:t>• push_model.py slims the checkpoint (drops optimizer, ~⅓ size) and uploads model.ckpt + nameslist.json + config.json</a:t>
+            </a:r>
+          </a:p>
+          <a:p>
+            <a:pPr>
+              <a:spcBef>
+                <a:spcPts val="400"/>
+              </a:spcBef>
+            </a:pPr>
+            <a:r>
+              <a:rPr sz="1200">
+                <a:solidFill>
+                  <a:srgbClr val="1A2027"/>
+                </a:solidFill>
+              </a:rPr>
+              <a:t>• Repo tagged herbarium-pipeline → the Space discovers it automatically; tap ⟳ to refresh (no redeploy)</a:t>
+            </a:r>
+          </a:p>
+          <a:p>
+            <a:pPr>
+              <a:spcBef>
+                <a:spcPts val="400"/>
+              </a:spcBef>
+            </a:pPr>
+            <a:r>
+              <a:rPr sz="1200">
+                <a:solidFill>
+                  <a:srgbClr val="1A2027"/>
+                </a:solidFill>
+              </a:rPr>
+              <a:t>• config.json carries image size, label rank, and a calibration temperature so confidence is honest, not ~100 %</a:t>
+            </a:r>
+          </a:p>
+          <a:p>
+            <a:pPr>
+              <a:spcBef>
+                <a:spcPts val="400"/>
+              </a:spcBef>
+            </a:pPr>
+            <a:r>
+              <a:rPr sz="1200">
+                <a:solidFill>
+                  <a:srgbClr val="1A2027"/>
+                </a:solidFill>
+              </a:rPr>
+              <a:t>• One-time  huggingface-cli login  with a write token</a:t>
+            </a:r>
+          </a:p>
+        </p:txBody>
+      </p:sp>
+      <p:sp>
+        <p:nvSpPr>
+          <p:cNvPr id="17" name="Rectangle 16"/>
+          <p:cNvSpPr/>
+          <p:nvPr/>
+        </p:nvSpPr>
+        <p:spPr>
+          <a:xfrm>
+            <a:off x="365760" y="5148071"/>
+            <a:ext cx="5577840" cy="548640"/>
+          </a:xfrm>
+          <a:prstGeom prst="rect">
+            <a:avLst/>
+          </a:prstGeom>
+          <a:solidFill>
+            <a:srgbClr val="1A2027"/>
+          </a:solidFill>
+          <a:ln>
+            <a:noFill/>
+          </a:ln>
+        </p:spPr>
+        <p:style>
+          <a:lnRef idx="1">
+            <a:schemeClr val="accent1"/>
+          </a:lnRef>
+          <a:fillRef idx="3">
+            <a:schemeClr val="accent1"/>
+          </a:fillRef>
+          <a:effectRef idx="2">
+            <a:schemeClr val="accent1"/>
+          </a:effectRef>
+          <a:fontRef idx="minor">
+            <a:schemeClr val="lt1"/>
+          </a:fontRef>
+        </p:style>
+        <p:txBody>
+          <a:bodyPr rtlCol="0" anchor="ctr"/>
+          <a:lstStyle/>
+          <a:p>
+            <a:pPr algn="ctr"/>
+          </a:p>
+        </p:txBody>
+      </p:sp>
+      <p:sp>
+        <p:nvSpPr>
+          <p:cNvPr id="18" name="TextBox 17"/>
+          <p:cNvSpPr txBox="1"/>
+          <p:nvPr/>
+        </p:nvSpPr>
+        <p:spPr>
+          <a:xfrm>
+            <a:off x="502920" y="5212080"/>
+            <a:ext cx="5394960" cy="457200"/>
+          </a:xfrm>
+          <a:prstGeom prst="rect">
+            <a:avLst/>
+          </a:prstGeom>
+          <a:noFill/>
+        </p:spPr>
+        <p:txBody>
+          <a:bodyPr wrap="square">
+            <a:spAutoFit/>
+          </a:bodyPr>
+          <a:lstStyle/>
+          <a:p>
+            <a:pPr algn="l"/>
+            <a:r>
+              <a:rPr sz="1000" b="0" i="0">
+                <a:solidFill>
+                  <a:srgbClr val="80CBC4"/>
+                </a:solidFill>
+              </a:rPr>
+              <a:t>python space/push_model.py --ckpt … --family Ebenaceae --hf-user &lt;you&gt;</a:t>
+            </a:r>
+          </a:p>
+        </p:txBody>
+      </p:sp>
+      <p:sp>
+        <p:nvSpPr>
+          <p:cNvPr id="19" name="TextBox 18"/>
+          <p:cNvSpPr txBox="1"/>
+          <p:nvPr/>
+        </p:nvSpPr>
+        <p:spPr>
+          <a:xfrm>
+            <a:off x="6309360" y="2633472"/>
+            <a:ext cx="3657600" cy="365760"/>
+          </a:xfrm>
+          <a:prstGeom prst="rect">
+            <a:avLst/>
+          </a:prstGeom>
+          <a:noFill/>
+        </p:spPr>
+        <p:txBody>
+          <a:bodyPr wrap="square">
+            <a:spAutoFit/>
+          </a:bodyPr>
+          <a:lstStyle/>
+          <a:p>
+            <a:pPr algn="l"/>
+            <a:r>
+              <a:rPr sz="1400" b="1" i="0">
+                <a:solidFill>
+                  <a:srgbClr val="00695C"/>
+                </a:solidFill>
+              </a:rPr>
+              <a:t>On a phone</a:t>
+            </a:r>
+          </a:p>
+        </p:txBody>
+      </p:sp>
+      <p:sp>
+        <p:nvSpPr>
+          <p:cNvPr id="20" name="TextBox 19"/>
+          <p:cNvSpPr txBox="1"/>
+          <p:nvPr/>
+        </p:nvSpPr>
+        <p:spPr>
+          <a:xfrm>
+            <a:off x="6309360" y="3044951"/>
+            <a:ext cx="3840480" cy="2377440"/>
+          </a:xfrm>
+          <a:prstGeom prst="rect">
+            <a:avLst/>
+          </a:prstGeom>
+          <a:noFill/>
+        </p:spPr>
+        <p:txBody>
+          <a:bodyPr wrap="square">
+            <a:spAutoFit/>
+          </a:bodyPr>
+          <a:lstStyle/>
+          <a:p>
+            <a:pPr>
+              <a:spcBef>
+                <a:spcPts val="400"/>
+              </a:spcBef>
+            </a:pPr>
+            <a:r>
+              <a:rPr sz="1200">
+                <a:solidFill>
+                  <a:srgbClr val="1A2027"/>
+                </a:solidFill>
+              </a:rPr>
+              <a:t>• Open the Space URL in any phone browser — nothing to install</a:t>
+            </a:r>
+          </a:p>
+          <a:p>
+            <a:pPr>
+              <a:spcBef>
+                <a:spcPts val="400"/>
+              </a:spcBef>
+            </a:pPr>
+            <a:r>
+              <a:rPr sz="1200">
+                <a:solidFill>
+                  <a:srgbClr val="1A2027"/>
+                </a:solidFill>
+              </a:rPr>
+              <a:t>• Pick a model, tap to photograph a sheet with the rear camera</a:t>
+            </a:r>
+          </a:p>
+          <a:p>
+            <a:pPr>
+              <a:spcBef>
+                <a:spcPts val="400"/>
+              </a:spcBef>
+            </a:pPr>
+            <a:r>
+              <a:rPr sz="1200">
+                <a:solidFill>
+                  <a:srgbClr val="1A2027"/>
+                </a:solidFill>
+              </a:rPr>
+              <a:t>• Top-5 species / family + confidence in a second or two</a:t>
+            </a:r>
+          </a:p>
+          <a:p>
+            <a:pPr>
+              <a:spcBef>
+                <a:spcPts val="400"/>
+              </a:spcBef>
+            </a:pPr>
+            <a:r>
+              <a:rPr sz="1200">
+                <a:solidFill>
+                  <a:srgbClr val="1A2027"/>
+                </a:solidFill>
+              </a:rPr>
+              <a:t>• Optional lat/lon sharpens geo-aware models</a:t>
+            </a:r>
+          </a:p>
+        </p:txBody>
+      </p:sp>
+      <p:sp>
+        <p:nvSpPr>
+          <p:cNvPr id="21" name="Rounded Rectangle 20"/>
+          <p:cNvSpPr/>
+          <p:nvPr/>
+        </p:nvSpPr>
+        <p:spPr>
+          <a:xfrm>
+            <a:off x="10424160" y="2724912"/>
+            <a:ext cx="1371600" cy="2743200"/>
+          </a:xfrm>
+          <a:prstGeom prst="roundRect">
+            <a:avLst/>
+          </a:prstGeom>
+          <a:solidFill>
+            <a:srgbClr val="1A2027"/>
+          </a:solidFill>
+          <a:ln>
+            <a:noFill/>
+          </a:ln>
+        </p:spPr>
+        <p:style>
+          <a:lnRef idx="1">
+            <a:schemeClr val="accent1"/>
+          </a:lnRef>
+          <a:fillRef idx="3">
+            <a:schemeClr val="accent1"/>
+          </a:fillRef>
+          <a:effectRef idx="2">
+            <a:schemeClr val="accent1"/>
+          </a:effectRef>
+          <a:fontRef idx="minor">
+            <a:schemeClr val="lt1"/>
+          </a:fontRef>
+        </p:style>
+        <p:txBody>
+          <a:bodyPr rtlCol="0" anchor="ctr"/>
+          <a:lstStyle/>
+          <a:p>
+            <a:pPr algn="ctr"/>
+          </a:p>
+        </p:txBody>
+      </p:sp>
+      <p:sp>
+        <p:nvSpPr>
+          <p:cNvPr id="22" name="Rectangle 21"/>
+          <p:cNvSpPr/>
+          <p:nvPr/>
+        </p:nvSpPr>
+        <p:spPr>
+          <a:xfrm>
+            <a:off x="10515600" y="2889504"/>
+            <a:ext cx="1188720" cy="2414016"/>
+          </a:xfrm>
+          <a:prstGeom prst="rect">
+            <a:avLst/>
+          </a:prstGeom>
+          <a:solidFill>
+            <a:srgbClr val="FFFFFF"/>
+          </a:solidFill>
+          <a:ln>
+            <a:noFill/>
+          </a:ln>
+        </p:spPr>
+        <p:style>
+          <a:lnRef idx="1">
+            <a:schemeClr val="accent1"/>
+          </a:lnRef>
+          <a:fillRef idx="3">
+            <a:schemeClr val="accent1"/>
+          </a:fillRef>
+          <a:effectRef idx="2">
+            <a:schemeClr val="accent1"/>
+          </a:effectRef>
+          <a:fontRef idx="minor">
+            <a:schemeClr val="lt1"/>
+          </a:fontRef>
+        </p:style>
+        <p:txBody>
+          <a:bodyPr rtlCol="0" anchor="ctr"/>
+          <a:lstStyle/>
+          <a:p>
+            <a:pPr algn="ctr"/>
+          </a:p>
+        </p:txBody>
+      </p:sp>
+      <p:sp>
+        <p:nvSpPr>
+          <p:cNvPr id="23" name="Rectangle 22"/>
+          <p:cNvSpPr/>
+          <p:nvPr/>
+        </p:nvSpPr>
+        <p:spPr>
+          <a:xfrm>
+            <a:off x="10515600" y="2889504"/>
+            <a:ext cx="1188720" cy="292608"/>
+          </a:xfrm>
+          <a:prstGeom prst="rect">
+            <a:avLst/>
+          </a:prstGeom>
+          <a:solidFill>
+            <a:srgbClr val="2E7D32"/>
+          </a:solidFill>
+          <a:ln>
+            <a:noFill/>
+          </a:ln>
+        </p:spPr>
+        <p:style>
+          <a:lnRef idx="1">
+            <a:schemeClr val="accent1"/>
+          </a:lnRef>
+          <a:fillRef idx="3">
+            <a:schemeClr val="accent1"/>
+          </a:fillRef>
+          <a:effectRef idx="2">
+            <a:schemeClr val="accent1"/>
+          </a:effectRef>
+          <a:fontRef idx="minor">
+            <a:schemeClr val="lt1"/>
+          </a:fontRef>
+        </p:style>
+        <p:txBody>
+          <a:bodyPr rtlCol="0" anchor="ctr"/>
+          <a:lstStyle/>
+          <a:p>
+            <a:pPr algn="ctr"/>
+          </a:p>
+        </p:txBody>
+      </p:sp>
+      <p:sp>
+        <p:nvSpPr>
+          <p:cNvPr id="24" name="TextBox 23"/>
+          <p:cNvSpPr txBox="1"/>
+          <p:nvPr/>
+        </p:nvSpPr>
+        <p:spPr>
+          <a:xfrm>
+            <a:off x="10533888" y="2898648"/>
+            <a:ext cx="1152144" cy="274320"/>
+          </a:xfrm>
+          <a:prstGeom prst="rect">
+            <a:avLst/>
+          </a:prstGeom>
+          <a:noFill/>
+        </p:spPr>
+        <p:txBody>
+          <a:bodyPr wrap="square">
+            <a:spAutoFit/>
+          </a:bodyPr>
+          <a:lstStyle/>
+          <a:p>
+            <a:pPr algn="ctr"/>
+            <a:r>
+              <a:rPr sz="800" b="0" i="0">
+                <a:solidFill>
+                  <a:srgbClr val="FFFFFF"/>
+                </a:solidFill>
+              </a:rPr>
+              <a:t>🌿 Herbarium ID</a:t>
+            </a:r>
+          </a:p>
+        </p:txBody>
+      </p:sp>
+      <p:sp>
+        <p:nvSpPr>
+          <p:cNvPr id="25" name="Rectangle 24"/>
+          <p:cNvSpPr/>
+          <p:nvPr/>
+        </p:nvSpPr>
+        <p:spPr>
+          <a:xfrm>
+            <a:off x="10625328" y="3291840"/>
+            <a:ext cx="969264" cy="868680"/>
+          </a:xfrm>
+          <a:prstGeom prst="rect">
+            <a:avLst/>
+          </a:prstGeom>
+          <a:solidFill>
+            <a:srgbClr val="E0F2F1"/>
+          </a:solidFill>
+          <a:ln w="9525">
+            <a:solidFill>
+              <a:srgbClr val="CFD8DC"/>
+            </a:solidFill>
+          </a:ln>
+        </p:spPr>
+        <p:style>
+          <a:lnRef idx="1">
+            <a:schemeClr val="accent1"/>
+          </a:lnRef>
+          <a:fillRef idx="3">
+            <a:schemeClr val="accent1"/>
+          </a:fillRef>
+          <a:effectRef idx="2">
+            <a:schemeClr val="accent1"/>
+          </a:effectRef>
+          <a:fontRef idx="minor">
+            <a:schemeClr val="lt1"/>
+          </a:fontRef>
+        </p:style>
+        <p:txBody>
+          <a:bodyPr rtlCol="0" anchor="ctr"/>
+          <a:lstStyle/>
+          <a:p>
+            <a:pPr algn="ctr"/>
+          </a:p>
+        </p:txBody>
+      </p:sp>
+      <p:sp>
+        <p:nvSpPr>
+          <p:cNvPr id="26" name="TextBox 25"/>
+          <p:cNvSpPr txBox="1"/>
+          <p:nvPr/>
+        </p:nvSpPr>
+        <p:spPr>
+          <a:xfrm>
+            <a:off x="10625328" y="3529584"/>
+            <a:ext cx="969264" cy="457200"/>
+          </a:xfrm>
+          <a:prstGeom prst="rect">
+            <a:avLst/>
+          </a:prstGeom>
+          <a:noFill/>
+        </p:spPr>
+        <p:txBody>
+          <a:bodyPr wrap="square">
+            <a:spAutoFit/>
+          </a:bodyPr>
+          <a:lstStyle/>
+          <a:p>
+            <a:pPr algn="ctr"/>
+            <a:r>
+              <a:rPr sz="800" b="0" i="0">
+                <a:solidFill>
+                  <a:srgbClr val="455A64"/>
+                </a:solidFill>
+              </a:rPr>
+              <a:t>sheet
+photo</a:t>
+            </a:r>
+          </a:p>
+        </p:txBody>
+      </p:sp>
+      <p:sp>
+        <p:nvSpPr>
+          <p:cNvPr id="27" name="Rectangle 26"/>
+          <p:cNvSpPr/>
+          <p:nvPr/>
+        </p:nvSpPr>
+        <p:spPr>
+          <a:xfrm>
+            <a:off x="10625328" y="4279392"/>
+            <a:ext cx="872337" cy="182880"/>
+          </a:xfrm>
+          <a:prstGeom prst="rect">
+            <a:avLst/>
+          </a:prstGeom>
+          <a:solidFill>
+            <a:srgbClr val="00897B"/>
+          </a:solidFill>
+          <a:ln>
+            <a:noFill/>
+          </a:ln>
+        </p:spPr>
+        <p:style>
+          <a:lnRef idx="1">
+            <a:schemeClr val="accent1"/>
+          </a:lnRef>
+          <a:fillRef idx="3">
+            <a:schemeClr val="accent1"/>
+          </a:fillRef>
+          <a:effectRef idx="2">
+            <a:schemeClr val="accent1"/>
+          </a:effectRef>
+          <a:fontRef idx="minor">
+            <a:schemeClr val="lt1"/>
+          </a:fontRef>
+        </p:style>
+        <p:txBody>
+          <a:bodyPr rtlCol="0" anchor="ctr"/>
+          <a:lstStyle/>
+          <a:p>
+            <a:pPr algn="ctr"/>
+          </a:p>
+        </p:txBody>
+      </p:sp>
+      <p:sp>
+        <p:nvSpPr>
+          <p:cNvPr id="28" name="Rectangle 27"/>
+          <p:cNvSpPr/>
+          <p:nvPr/>
+        </p:nvSpPr>
+        <p:spPr>
+          <a:xfrm>
+            <a:off x="10625328" y="4572000"/>
+            <a:ext cx="581558" cy="182880"/>
+          </a:xfrm>
+          <a:prstGeom prst="rect">
+            <a:avLst/>
+          </a:prstGeom>
+          <a:solidFill>
+            <a:srgbClr val="80CBC4"/>
+          </a:solidFill>
+          <a:ln>
+            <a:noFill/>
+          </a:ln>
+        </p:spPr>
+        <p:style>
+          <a:lnRef idx="1">
+            <a:schemeClr val="accent1"/>
+          </a:lnRef>
+          <a:fillRef idx="3">
+            <a:schemeClr val="accent1"/>
+          </a:fillRef>
+          <a:effectRef idx="2">
+            <a:schemeClr val="accent1"/>
+          </a:effectRef>
+          <a:fontRef idx="minor">
+            <a:schemeClr val="lt1"/>
+          </a:fontRef>
+        </p:style>
+        <p:txBody>
+          <a:bodyPr rtlCol="0" anchor="ctr"/>
+          <a:lstStyle/>
+          <a:p>
+            <a:pPr algn="ctr"/>
+          </a:p>
+        </p:txBody>
+      </p:sp>
+      <p:sp>
+        <p:nvSpPr>
+          <p:cNvPr id="29" name="Rectangle 28"/>
+          <p:cNvSpPr/>
+          <p:nvPr/>
+        </p:nvSpPr>
+        <p:spPr>
+          <a:xfrm>
+            <a:off x="10625328" y="4864608"/>
+            <a:ext cx="387705" cy="182880"/>
+          </a:xfrm>
+          <a:prstGeom prst="rect">
+            <a:avLst/>
+          </a:prstGeom>
+          <a:solidFill>
+            <a:srgbClr val="80CBC4"/>
+          </a:solidFill>
+          <a:ln>
+            <a:noFill/>
+          </a:ln>
+        </p:spPr>
+        <p:style>
+          <a:lnRef idx="1">
+            <a:schemeClr val="accent1"/>
+          </a:lnRef>
+          <a:fillRef idx="3">
+            <a:schemeClr val="accent1"/>
+          </a:fillRef>
+          <a:effectRef idx="2">
+            <a:schemeClr val="accent1"/>
+          </a:effectRef>
+          <a:fontRef idx="minor">
+            <a:schemeClr val="lt1"/>
+          </a:fontRef>
+        </p:style>
+        <p:txBody>
+          <a:bodyPr rtlCol="0" anchor="ctr"/>
+          <a:lstStyle/>
+          <a:p>
+            <a:pPr algn="ctr"/>
+          </a:p>
+        </p:txBody>
+      </p:sp>
+      <p:sp>
+        <p:nvSpPr>
+          <p:cNvPr id="30" name="Rectangle 29"/>
+          <p:cNvSpPr/>
+          <p:nvPr/>
+        </p:nvSpPr>
+        <p:spPr>
+          <a:xfrm>
+            <a:off x="365760" y="5806440"/>
+            <a:ext cx="11457432" cy="502920"/>
+          </a:xfrm>
+          <a:prstGeom prst="rect">
+            <a:avLst/>
+          </a:prstGeom>
+          <a:solidFill>
+            <a:srgbClr val="E0F2F1"/>
+          </a:solidFill>
+          <a:ln w="9525">
+            <a:solidFill>
+              <a:srgbClr val="80CBC4"/>
+            </a:solidFill>
+          </a:ln>
+        </p:spPr>
+        <p:style>
+          <a:lnRef idx="1">
+            <a:schemeClr val="accent1"/>
+          </a:lnRef>
+          <a:fillRef idx="3">
+            <a:schemeClr val="accent1"/>
+          </a:fillRef>
+          <a:effectRef idx="2">
+            <a:schemeClr val="accent1"/>
+          </a:effectRef>
+          <a:fontRef idx="minor">
+            <a:schemeClr val="lt1"/>
+          </a:fontRef>
+        </p:style>
+        <p:txBody>
+          <a:bodyPr rtlCol="0" anchor="ctr"/>
+          <a:lstStyle/>
+          <a:p>
+            <a:pPr algn="ctr"/>
+          </a:p>
+        </p:txBody>
+      </p:sp>
+      <p:sp>
+        <p:nvSpPr>
+          <p:cNvPr id="31" name="TextBox 30"/>
+          <p:cNvSpPr txBox="1"/>
+          <p:nvPr/>
+        </p:nvSpPr>
+        <p:spPr>
+          <a:xfrm>
+            <a:off x="548640" y="5870448"/>
+            <a:ext cx="11155680" cy="384048"/>
+          </a:xfrm>
+          <a:prstGeom prst="rect">
+            <a:avLst/>
+          </a:prstGeom>
+          <a:noFill/>
+        </p:spPr>
+        <p:txBody>
+          <a:bodyPr wrap="square">
+            <a:spAutoFit/>
+          </a:bodyPr>
+          <a:lstStyle/>
+          <a:p>
+            <a:pPr algn="ctr"/>
+            <a:r>
+              <a:rPr sz="1200" b="1" i="0">
+                <a:solidFill>
+                  <a:srgbClr val="00695C"/>
+                </a:solidFill>
+              </a:rPr>
+              <a:t>Live now:  https://huggingface.co/spaces/ggosline/herbarium-id     ·     models: africa-angiosperms-family · olacaceae-species · uvaria-species</a:t>
             </a:r>
           </a:p>
         </p:txBody>

</xml_diff>